<commit_message>
Bugs fixed in threading
</commit_message>
<xml_diff>
--- a/FFNN/Reports/AWG_automation.pptx
+++ b/FFNN/Reports/AWG_automation.pptx
@@ -15,6 +15,10 @@
     <p:sldId id="267" r:id="rId12"/>
     <p:sldId id="268" r:id="rId13"/>
     <p:sldId id="269" r:id="rId14"/>
+    <p:sldId id="270" r:id="rId15"/>
+    <p:sldId id="271" r:id="rId16"/>
+    <p:sldId id="272" r:id="rId17"/>
+    <p:sldId id="273" r:id="rId18"/>
   </p:sldIdLst>
   <p:sldSz cx="12192000" cy="6858000"/>
   <p:notesSz cx="6858000" cy="9144000"/>
@@ -131,6 +135,87 @@
 
 <file path=ppt/changesInfos/changesInfo1.xml><?xml version="1.0" encoding="utf-8"?>
 <pc:chgInfo xmlns:a="http://schemas.openxmlformats.org/drawingml/2006/main" xmlns:r="http://schemas.openxmlformats.org/officeDocument/2006/relationships" xmlns:ac="http://schemas.microsoft.com/office/drawing/2013/main/command" xmlns:pc="http://schemas.microsoft.com/office/powerpoint/2013/main/command">
+  <pc:docChgLst>
+    <pc:chgData name="Vijayanand Kuttikattu Vadakeppattu" userId="844320508617db3f" providerId="LiveId" clId="{1EDF5282-0F2B-4586-ACFA-DF0B860ACE6E}"/>
+    <pc:docChg chg="undo custSel addSld delSld modSld">
+      <pc:chgData name="Vijayanand Kuttikattu Vadakeppattu" userId="844320508617db3f" providerId="LiveId" clId="{1EDF5282-0F2B-4586-ACFA-DF0B860ACE6E}" dt="2025-07-29T09:50:50.365" v="954" actId="5793"/>
+      <pc:docMkLst>
+        <pc:docMk/>
+      </pc:docMkLst>
+      <pc:sldChg chg="addSp delSp modSp new mod">
+        <pc:chgData name="Vijayanand Kuttikattu Vadakeppattu" userId="844320508617db3f" providerId="LiveId" clId="{1EDF5282-0F2B-4586-ACFA-DF0B860ACE6E}" dt="2025-07-22T08:35:49.478" v="218" actId="20577"/>
+        <pc:sldMkLst>
+          <pc:docMk/>
+          <pc:sldMk cId="312211764" sldId="259"/>
+        </pc:sldMkLst>
+      </pc:sldChg>
+      <pc:sldChg chg="addSp delSp modSp new mod">
+        <pc:chgData name="Vijayanand Kuttikattu Vadakeppattu" userId="844320508617db3f" providerId="LiveId" clId="{1EDF5282-0F2B-4586-ACFA-DF0B860ACE6E}" dt="2025-07-22T06:11:01.071" v="119" actId="20577"/>
+        <pc:sldMkLst>
+          <pc:docMk/>
+          <pc:sldMk cId="2596736845" sldId="260"/>
+        </pc:sldMkLst>
+      </pc:sldChg>
+      <pc:sldChg chg="addSp delSp modSp new mod">
+        <pc:chgData name="Vijayanand Kuttikattu Vadakeppattu" userId="844320508617db3f" providerId="LiveId" clId="{1EDF5282-0F2B-4586-ACFA-DF0B860ACE6E}" dt="2025-07-22T06:14:06.713" v="160" actId="1076"/>
+        <pc:sldMkLst>
+          <pc:docMk/>
+          <pc:sldMk cId="1983806369" sldId="261"/>
+        </pc:sldMkLst>
+      </pc:sldChg>
+      <pc:sldChg chg="addSp delSp modSp new mod">
+        <pc:chgData name="Vijayanand Kuttikattu Vadakeppattu" userId="844320508617db3f" providerId="LiveId" clId="{1EDF5282-0F2B-4586-ACFA-DF0B860ACE6E}" dt="2025-07-29T09:34:41.973" v="601" actId="478"/>
+        <pc:sldMkLst>
+          <pc:docMk/>
+          <pc:sldMk cId="3106166370" sldId="262"/>
+        </pc:sldMkLst>
+      </pc:sldChg>
+      <pc:sldChg chg="addSp delSp modSp new del mod">
+        <pc:chgData name="Vijayanand Kuttikattu Vadakeppattu" userId="844320508617db3f" providerId="LiveId" clId="{1EDF5282-0F2B-4586-ACFA-DF0B860ACE6E}" dt="2025-07-22T08:34:53.812" v="198" actId="47"/>
+        <pc:sldMkLst>
+          <pc:docMk/>
+          <pc:sldMk cId="3375564553" sldId="262"/>
+        </pc:sldMkLst>
+      </pc:sldChg>
+      <pc:sldChg chg="addSp delSp modSp new mod">
+        <pc:chgData name="Vijayanand Kuttikattu Vadakeppattu" userId="844320508617db3f" providerId="LiveId" clId="{1EDF5282-0F2B-4586-ACFA-DF0B860ACE6E}" dt="2025-07-29T09:40:00.947" v="644" actId="122"/>
+        <pc:sldMkLst>
+          <pc:docMk/>
+          <pc:sldMk cId="3699315126" sldId="263"/>
+        </pc:sldMkLst>
+      </pc:sldChg>
+      <pc:sldChg chg="addSp delSp modSp new mod">
+        <pc:chgData name="Vijayanand Kuttikattu Vadakeppattu" userId="844320508617db3f" providerId="LiveId" clId="{1EDF5282-0F2B-4586-ACFA-DF0B860ACE6E}" dt="2025-07-29T09:49:36.842" v="827" actId="14100"/>
+        <pc:sldMkLst>
+          <pc:docMk/>
+          <pc:sldMk cId="631309456" sldId="264"/>
+        </pc:sldMkLst>
+        <pc:spChg chg="mod">
+          <ac:chgData name="Vijayanand Kuttikattu Vadakeppattu" userId="844320508617db3f" providerId="LiveId" clId="{1EDF5282-0F2B-4586-ACFA-DF0B860ACE6E}" dt="2025-07-29T09:41:12.593" v="679" actId="122"/>
+          <ac:spMkLst>
+            <pc:docMk/>
+            <pc:sldMk cId="631309456" sldId="264"/>
+            <ac:spMk id="2" creationId="{3D57A138-2B6A-2048-0E2C-278A67E6D1FE}"/>
+          </ac:spMkLst>
+        </pc:spChg>
+        <pc:spChg chg="add del mod">
+          <ac:chgData name="Vijayanand Kuttikattu Vadakeppattu" userId="844320508617db3f" providerId="LiveId" clId="{1EDF5282-0F2B-4586-ACFA-DF0B860ACE6E}" dt="2025-07-29T09:43:43.154" v="689" actId="47"/>
+          <ac:spMkLst>
+            <pc:docMk/>
+            <pc:sldMk cId="631309456" sldId="264"/>
+            <ac:spMk id="6" creationId="{3E4D087F-7D86-AB61-262B-5E50E7114A57}"/>
+          </ac:spMkLst>
+        </pc:spChg>
+      </pc:sldChg>
+      <pc:sldChg chg="modSp new mod">
+        <pc:chgData name="Vijayanand Kuttikattu Vadakeppattu" userId="844320508617db3f" providerId="LiveId" clId="{1EDF5282-0F2B-4586-ACFA-DF0B860ACE6E}" dt="2025-07-29T09:50:50.365" v="954" actId="5793"/>
+        <pc:sldMkLst>
+          <pc:docMk/>
+          <pc:sldMk cId="1350564121" sldId="265"/>
+        </pc:sldMkLst>
+      </pc:sldChg>
+    </pc:docChg>
+  </pc:docChgLst>
   <pc:docChgLst>
     <pc:chgData name="Vijayanand Kuttikattu Vadakeppattu" userId="844320508617db3f" providerId="LiveId" clId="{F5C5D5D4-DFE0-4839-A9C4-8B3CF899B12F}"/>
     <pc:docChg chg="custSel addSld delSld modSld">
@@ -389,87 +474,6 @@
       </pc:sldChg>
     </pc:docChg>
   </pc:docChgLst>
-  <pc:docChgLst>
-    <pc:chgData name="Vijayanand Kuttikattu Vadakeppattu" userId="844320508617db3f" providerId="LiveId" clId="{1EDF5282-0F2B-4586-ACFA-DF0B860ACE6E}"/>
-    <pc:docChg chg="undo custSel addSld delSld modSld">
-      <pc:chgData name="Vijayanand Kuttikattu Vadakeppattu" userId="844320508617db3f" providerId="LiveId" clId="{1EDF5282-0F2B-4586-ACFA-DF0B860ACE6E}" dt="2025-07-29T09:50:50.365" v="954" actId="5793"/>
-      <pc:docMkLst>
-        <pc:docMk/>
-      </pc:docMkLst>
-      <pc:sldChg chg="addSp delSp modSp new mod">
-        <pc:chgData name="Vijayanand Kuttikattu Vadakeppattu" userId="844320508617db3f" providerId="LiveId" clId="{1EDF5282-0F2B-4586-ACFA-DF0B860ACE6E}" dt="2025-07-22T08:35:49.478" v="218" actId="20577"/>
-        <pc:sldMkLst>
-          <pc:docMk/>
-          <pc:sldMk cId="312211764" sldId="259"/>
-        </pc:sldMkLst>
-      </pc:sldChg>
-      <pc:sldChg chg="addSp delSp modSp new mod">
-        <pc:chgData name="Vijayanand Kuttikattu Vadakeppattu" userId="844320508617db3f" providerId="LiveId" clId="{1EDF5282-0F2B-4586-ACFA-DF0B860ACE6E}" dt="2025-07-22T06:11:01.071" v="119" actId="20577"/>
-        <pc:sldMkLst>
-          <pc:docMk/>
-          <pc:sldMk cId="2596736845" sldId="260"/>
-        </pc:sldMkLst>
-      </pc:sldChg>
-      <pc:sldChg chg="addSp delSp modSp new mod">
-        <pc:chgData name="Vijayanand Kuttikattu Vadakeppattu" userId="844320508617db3f" providerId="LiveId" clId="{1EDF5282-0F2B-4586-ACFA-DF0B860ACE6E}" dt="2025-07-22T06:14:06.713" v="160" actId="1076"/>
-        <pc:sldMkLst>
-          <pc:docMk/>
-          <pc:sldMk cId="1983806369" sldId="261"/>
-        </pc:sldMkLst>
-      </pc:sldChg>
-      <pc:sldChg chg="addSp delSp modSp new mod">
-        <pc:chgData name="Vijayanand Kuttikattu Vadakeppattu" userId="844320508617db3f" providerId="LiveId" clId="{1EDF5282-0F2B-4586-ACFA-DF0B860ACE6E}" dt="2025-07-29T09:34:41.973" v="601" actId="478"/>
-        <pc:sldMkLst>
-          <pc:docMk/>
-          <pc:sldMk cId="3106166370" sldId="262"/>
-        </pc:sldMkLst>
-      </pc:sldChg>
-      <pc:sldChg chg="addSp delSp modSp new del mod">
-        <pc:chgData name="Vijayanand Kuttikattu Vadakeppattu" userId="844320508617db3f" providerId="LiveId" clId="{1EDF5282-0F2B-4586-ACFA-DF0B860ACE6E}" dt="2025-07-22T08:34:53.812" v="198" actId="47"/>
-        <pc:sldMkLst>
-          <pc:docMk/>
-          <pc:sldMk cId="3375564553" sldId="262"/>
-        </pc:sldMkLst>
-      </pc:sldChg>
-      <pc:sldChg chg="addSp delSp modSp new mod">
-        <pc:chgData name="Vijayanand Kuttikattu Vadakeppattu" userId="844320508617db3f" providerId="LiveId" clId="{1EDF5282-0F2B-4586-ACFA-DF0B860ACE6E}" dt="2025-07-29T09:40:00.947" v="644" actId="122"/>
-        <pc:sldMkLst>
-          <pc:docMk/>
-          <pc:sldMk cId="3699315126" sldId="263"/>
-        </pc:sldMkLst>
-      </pc:sldChg>
-      <pc:sldChg chg="addSp delSp modSp new mod">
-        <pc:chgData name="Vijayanand Kuttikattu Vadakeppattu" userId="844320508617db3f" providerId="LiveId" clId="{1EDF5282-0F2B-4586-ACFA-DF0B860ACE6E}" dt="2025-07-29T09:49:36.842" v="827" actId="14100"/>
-        <pc:sldMkLst>
-          <pc:docMk/>
-          <pc:sldMk cId="631309456" sldId="264"/>
-        </pc:sldMkLst>
-        <pc:spChg chg="mod">
-          <ac:chgData name="Vijayanand Kuttikattu Vadakeppattu" userId="844320508617db3f" providerId="LiveId" clId="{1EDF5282-0F2B-4586-ACFA-DF0B860ACE6E}" dt="2025-07-29T09:41:12.593" v="679" actId="122"/>
-          <ac:spMkLst>
-            <pc:docMk/>
-            <pc:sldMk cId="631309456" sldId="264"/>
-            <ac:spMk id="2" creationId="{3D57A138-2B6A-2048-0E2C-278A67E6D1FE}"/>
-          </ac:spMkLst>
-        </pc:spChg>
-        <pc:spChg chg="add del mod">
-          <ac:chgData name="Vijayanand Kuttikattu Vadakeppattu" userId="844320508617db3f" providerId="LiveId" clId="{1EDF5282-0F2B-4586-ACFA-DF0B860ACE6E}" dt="2025-07-29T09:43:43.154" v="689" actId="47"/>
-          <ac:spMkLst>
-            <pc:docMk/>
-            <pc:sldMk cId="631309456" sldId="264"/>
-            <ac:spMk id="6" creationId="{3E4D087F-7D86-AB61-262B-5E50E7114A57}"/>
-          </ac:spMkLst>
-        </pc:spChg>
-      </pc:sldChg>
-      <pc:sldChg chg="modSp new mod">
-        <pc:chgData name="Vijayanand Kuttikattu Vadakeppattu" userId="844320508617db3f" providerId="LiveId" clId="{1EDF5282-0F2B-4586-ACFA-DF0B860ACE6E}" dt="2025-07-29T09:50:50.365" v="954" actId="5793"/>
-        <pc:sldMkLst>
-          <pc:docMk/>
-          <pc:sldMk cId="1350564121" sldId="265"/>
-        </pc:sldMkLst>
-      </pc:sldChg>
-    </pc:docChg>
-  </pc:docChgLst>
 </pc:chgInfo>
 </file>
 
@@ -711,7 +715,7 @@
           <a:p>
             <a:fld id="{ED291B17-9318-49DB-B28B-6E5994AE9581}" type="datetime1">
               <a:rPr lang="en-US" smtClean="0"/>
-              <a:t>8/26/2025</a:t>
+              <a:t>9/2/2025</a:t>
             </a:fld>
             <a:endParaRPr lang="en-US" dirty="0"/>
           </a:p>
@@ -914,7 +918,7 @@
           <a:p>
             <a:fld id="{2CED4963-E985-44C4-B8C4-FDD613B7C2F8}" type="datetime1">
               <a:rPr lang="en-US" smtClean="0"/>
-              <a:t>8/26/2025</a:t>
+              <a:t>9/2/2025</a:t>
             </a:fld>
             <a:endParaRPr lang="en-US" dirty="0"/>
           </a:p>
@@ -1276,7 +1280,7 @@
           <a:p>
             <a:fld id="{ED291B17-9318-49DB-B28B-6E5994AE9581}" type="datetime1">
               <a:rPr lang="en-US" smtClean="0"/>
-              <a:t>8/26/2025</a:t>
+              <a:t>9/2/2025</a:t>
             </a:fld>
             <a:endParaRPr lang="en-US" dirty="0"/>
           </a:p>
@@ -1474,7 +1478,7 @@
           <a:p>
             <a:fld id="{78DD82B9-B8EE-4375-B6FF-88FA6ABB15D9}" type="datetime1">
               <a:rPr lang="en-US" smtClean="0"/>
-              <a:t>8/26/2025</a:t>
+              <a:t>9/2/2025</a:t>
             </a:fld>
             <a:endParaRPr lang="en-US" dirty="0"/>
           </a:p>
@@ -1786,7 +1790,7 @@
           <a:p>
             <a:fld id="{B2497495-0637-405E-AE64-5CC7506D51F5}" type="datetime1">
               <a:rPr lang="en-US" smtClean="0"/>
-              <a:t>8/26/2025</a:t>
+              <a:t>9/2/2025</a:t>
             </a:fld>
             <a:endParaRPr lang="en-US" dirty="0"/>
           </a:p>
@@ -2039,7 +2043,7 @@
           <a:p>
             <a:fld id="{7BFFD690-9426-415D-8B65-26881E07B2D4}" type="datetime1">
               <a:rPr lang="en-US" smtClean="0"/>
-              <a:t>8/26/2025</a:t>
+              <a:t>9/2/2025</a:t>
             </a:fld>
             <a:endParaRPr lang="en-US" dirty="0"/>
           </a:p>
@@ -2461,7 +2465,7 @@
           <a:p>
             <a:fld id="{04C4989A-474C-40DE-95B9-011C28B71673}" type="datetime1">
               <a:rPr lang="en-US" smtClean="0"/>
-              <a:t>8/26/2025</a:t>
+              <a:t>9/2/2025</a:t>
             </a:fld>
             <a:endParaRPr lang="en-US" dirty="0"/>
           </a:p>
@@ -2584,7 +2588,7 @@
           <a:p>
             <a:fld id="{5DB4ED54-5B5E-4A04-93D3-5772E3CE3818}" type="datetime1">
               <a:rPr lang="en-US" smtClean="0"/>
-              <a:t>8/26/2025</a:t>
+              <a:t>9/2/2025</a:t>
             </a:fld>
             <a:endParaRPr lang="en-US" dirty="0"/>
           </a:p>
@@ -2679,7 +2683,7 @@
           <a:p>
             <a:fld id="{4EDE50D6-574B-40AF-946F-D52A04ADE379}" type="datetime1">
               <a:rPr lang="en-US" smtClean="0"/>
-              <a:t>8/26/2025</a:t>
+              <a:t>9/2/2025</a:t>
             </a:fld>
             <a:endParaRPr lang="en-US" dirty="0"/>
           </a:p>
@@ -3056,7 +3060,7 @@
           <a:p>
             <a:fld id="{D82884F1-FFEA-405F-9602-3DCA865EDA4E}" type="datetime1">
               <a:rPr lang="en-US" smtClean="0"/>
-              <a:t>8/26/2025</a:t>
+              <a:t>9/2/2025</a:t>
             </a:fld>
             <a:endParaRPr lang="en-US" dirty="0"/>
           </a:p>
@@ -3349,7 +3353,7 @@
           <a:p>
             <a:fld id="{7E18DB4A-8810-4A10-AD5C-D5E2C667F5B3}" type="datetime1">
               <a:rPr lang="en-US" smtClean="0"/>
-              <a:t>8/26/2025</a:t>
+              <a:t>9/2/2025</a:t>
             </a:fld>
             <a:endParaRPr lang="en-US" dirty="0"/>
           </a:p>
@@ -3564,7 +3568,7 @@
           <a:p>
             <a:fld id="{ED291B17-9318-49DB-B28B-6E5994AE9581}" type="datetime1">
               <a:rPr lang="en-US" smtClean="0"/>
-              <a:t>8/26/2025</a:t>
+              <a:t>9/2/2025</a:t>
             </a:fld>
             <a:endParaRPr lang="en-US" dirty="0"/>
           </a:p>
@@ -4604,6 +4608,520 @@
 </p:sld>
 </file>
 
+<file path=ppt/slides/slide11.xml><?xml version="1.0" encoding="utf-8"?>
+<p:sld xmlns:a="http://schemas.openxmlformats.org/drawingml/2006/main" xmlns:r="http://schemas.openxmlformats.org/officeDocument/2006/relationships" xmlns:p="http://schemas.openxmlformats.org/presentationml/2006/main">
+  <p:cSld>
+    <p:spTree>
+      <p:nvGrpSpPr>
+        <p:cNvPr id="1" name=""/>
+        <p:cNvGrpSpPr/>
+        <p:nvPr/>
+      </p:nvGrpSpPr>
+      <p:grpSpPr>
+        <a:xfrm>
+          <a:off x="0" y="0"/>
+          <a:ext cx="0" cy="0"/>
+          <a:chOff x="0" y="0"/>
+          <a:chExt cx="0" cy="0"/>
+        </a:xfrm>
+      </p:grpSpPr>
+      <p:sp>
+        <p:nvSpPr>
+          <p:cNvPr id="2" name="Title 1">
+            <a:extLst>
+              <a:ext uri="{FF2B5EF4-FFF2-40B4-BE49-F238E27FC236}">
+                <a16:creationId xmlns:a16="http://schemas.microsoft.com/office/drawing/2014/main" id="{78E981A8-561D-D8A4-3E7D-98F5B35E0104}"/>
+              </a:ext>
+            </a:extLst>
+          </p:cNvPr>
+          <p:cNvSpPr>
+            <a:spLocks noGrp="1"/>
+          </p:cNvSpPr>
+          <p:nvPr>
+            <p:ph type="title"/>
+          </p:nvPr>
+        </p:nvSpPr>
+        <p:spPr>
+          <a:xfrm>
+            <a:off x="581192" y="702156"/>
+            <a:ext cx="11029616" cy="635325"/>
+          </a:xfrm>
+        </p:spPr>
+        <p:txBody>
+          <a:bodyPr/>
+          <a:lstStyle/>
+          <a:p>
+            <a:pPr algn="ctr"/>
+            <a:r>
+              <a:rPr lang="en-IN" dirty="0"/>
+              <a:t>Output of </a:t>
+            </a:r>
+            <a:r>
+              <a:rPr lang="en-IN" dirty="0" err="1"/>
+              <a:t>lfm</a:t>
+            </a:r>
+            <a:r>
+              <a:rPr lang="en-IN" dirty="0"/>
+              <a:t> generated using </a:t>
+            </a:r>
+            <a:r>
+              <a:rPr lang="en-IN" dirty="0" err="1"/>
+              <a:t>iq</a:t>
+            </a:r>
+            <a:r>
+              <a:rPr lang="en-IN" dirty="0"/>
+              <a:t> tools software</a:t>
+            </a:r>
+          </a:p>
+        </p:txBody>
+      </p:sp>
+      <p:pic>
+        <p:nvPicPr>
+          <p:cNvPr id="5" name="Content Placeholder 4" descr="A graph of a sound wave&#10;&#10;AI-generated content may be incorrect.">
+            <a:extLst>
+              <a:ext uri="{FF2B5EF4-FFF2-40B4-BE49-F238E27FC236}">
+                <a16:creationId xmlns:a16="http://schemas.microsoft.com/office/drawing/2014/main" id="{BBA4D331-3053-50EB-71A5-01993A47E0AF}"/>
+              </a:ext>
+            </a:extLst>
+          </p:cNvPr>
+          <p:cNvPicPr>
+            <a:picLocks noGrp="1" noChangeAspect="1"/>
+          </p:cNvPicPr>
+          <p:nvPr>
+            <p:ph idx="1"/>
+          </p:nvPr>
+        </p:nvPicPr>
+        <p:blipFill>
+          <a:blip r:embed="rId2"/>
+          <a:stretch>
+            <a:fillRect/>
+          </a:stretch>
+        </p:blipFill>
+        <p:spPr>
+          <a:xfrm>
+            <a:off x="351478" y="1571611"/>
+            <a:ext cx="5878725" cy="3424333"/>
+          </a:xfrm>
+        </p:spPr>
+      </p:pic>
+      <p:pic>
+        <p:nvPicPr>
+          <p:cNvPr id="7" name="Picture 6" descr="A blue line graph with text&#10;&#10;AI-generated content may be incorrect.">
+            <a:extLst>
+              <a:ext uri="{FF2B5EF4-FFF2-40B4-BE49-F238E27FC236}">
+                <a16:creationId xmlns:a16="http://schemas.microsoft.com/office/drawing/2014/main" id="{83EC29E9-273C-D1AF-2B29-003C1E472418}"/>
+              </a:ext>
+            </a:extLst>
+          </p:cNvPr>
+          <p:cNvPicPr>
+            <a:picLocks noChangeAspect="1"/>
+          </p:cNvPicPr>
+          <p:nvPr/>
+        </p:nvPicPr>
+        <p:blipFill>
+          <a:blip r:embed="rId3"/>
+          <a:stretch>
+            <a:fillRect/>
+          </a:stretch>
+        </p:blipFill>
+        <p:spPr>
+          <a:xfrm>
+            <a:off x="6625989" y="1681658"/>
+            <a:ext cx="5442470" cy="3204241"/>
+          </a:xfrm>
+          <a:prstGeom prst="rect">
+            <a:avLst/>
+          </a:prstGeom>
+        </p:spPr>
+      </p:pic>
+    </p:spTree>
+    <p:extLst>
+      <p:ext uri="{BB962C8B-B14F-4D97-AF65-F5344CB8AC3E}">
+        <p14:creationId xmlns:p14="http://schemas.microsoft.com/office/powerpoint/2010/main" val="519772655"/>
+      </p:ext>
+    </p:extLst>
+  </p:cSld>
+  <p:clrMapOvr>
+    <a:masterClrMapping/>
+  </p:clrMapOvr>
+</p:sld>
+</file>
+
+<file path=ppt/slides/slide12.xml><?xml version="1.0" encoding="utf-8"?>
+<p:sld xmlns:a="http://schemas.openxmlformats.org/drawingml/2006/main" xmlns:r="http://schemas.openxmlformats.org/officeDocument/2006/relationships" xmlns:p="http://schemas.openxmlformats.org/presentationml/2006/main">
+  <p:cSld>
+    <p:spTree>
+      <p:nvGrpSpPr>
+        <p:cNvPr id="1" name=""/>
+        <p:cNvGrpSpPr/>
+        <p:nvPr/>
+      </p:nvGrpSpPr>
+      <p:grpSpPr>
+        <a:xfrm>
+          <a:off x="0" y="0"/>
+          <a:ext cx="0" cy="0"/>
+          <a:chOff x="0" y="0"/>
+          <a:chExt cx="0" cy="0"/>
+        </a:xfrm>
+      </p:grpSpPr>
+      <p:sp>
+        <p:nvSpPr>
+          <p:cNvPr id="2" name="Title 1">
+            <a:extLst>
+              <a:ext uri="{FF2B5EF4-FFF2-40B4-BE49-F238E27FC236}">
+                <a16:creationId xmlns:a16="http://schemas.microsoft.com/office/drawing/2014/main" id="{EBA585CB-8ACC-210E-CA1B-DE6C2BA3E44E}"/>
+              </a:ext>
+            </a:extLst>
+          </p:cNvPr>
+          <p:cNvSpPr>
+            <a:spLocks noGrp="1"/>
+          </p:cNvSpPr>
+          <p:nvPr>
+            <p:ph type="title"/>
+          </p:nvPr>
+        </p:nvSpPr>
+        <p:spPr>
+          <a:xfrm>
+            <a:off x="581192" y="702156"/>
+            <a:ext cx="11029616" cy="532966"/>
+          </a:xfrm>
+        </p:spPr>
+        <p:txBody>
+          <a:bodyPr/>
+          <a:lstStyle/>
+          <a:p>
+            <a:pPr algn="ctr"/>
+            <a:r>
+              <a:rPr lang="en-IN" dirty="0"/>
+              <a:t>Output of </a:t>
+            </a:r>
+            <a:r>
+              <a:rPr lang="en-IN" dirty="0" err="1"/>
+              <a:t>lfm</a:t>
+            </a:r>
+            <a:r>
+              <a:rPr lang="en-IN" dirty="0"/>
+              <a:t> generated using </a:t>
+            </a:r>
+            <a:r>
+              <a:rPr lang="en-IN" dirty="0" err="1"/>
+              <a:t>gui</a:t>
+            </a:r>
+            <a:endParaRPr lang="en-IN" dirty="0"/>
+          </a:p>
+        </p:txBody>
+      </p:sp>
+      <p:pic>
+        <p:nvPicPr>
+          <p:cNvPr id="5" name="Content Placeholder 4" descr="A blue line graph with white text&#10;&#10;AI-generated content may be incorrect.">
+            <a:extLst>
+              <a:ext uri="{FF2B5EF4-FFF2-40B4-BE49-F238E27FC236}">
+                <a16:creationId xmlns:a16="http://schemas.microsoft.com/office/drawing/2014/main" id="{F8BE14B1-BCFF-ABF6-FD7A-DF9E1CC759F8}"/>
+              </a:ext>
+            </a:extLst>
+          </p:cNvPr>
+          <p:cNvPicPr>
+            <a:picLocks noGrp="1" noChangeAspect="1"/>
+          </p:cNvPicPr>
+          <p:nvPr>
+            <p:ph idx="1"/>
+          </p:nvPr>
+        </p:nvPicPr>
+        <p:blipFill>
+          <a:blip r:embed="rId2"/>
+          <a:stretch>
+            <a:fillRect/>
+          </a:stretch>
+        </p:blipFill>
+        <p:spPr>
+          <a:xfrm>
+            <a:off x="6243850" y="1693294"/>
+            <a:ext cx="5101963" cy="3633787"/>
+          </a:xfrm>
+        </p:spPr>
+      </p:pic>
+      <p:pic>
+        <p:nvPicPr>
+          <p:cNvPr id="7" name="Picture 6" descr="A graph of a sound wave&#10;&#10;AI-generated content may be incorrect.">
+            <a:extLst>
+              <a:ext uri="{FF2B5EF4-FFF2-40B4-BE49-F238E27FC236}">
+                <a16:creationId xmlns:a16="http://schemas.microsoft.com/office/drawing/2014/main" id="{0FD1A9F4-E065-08E8-F355-C6C4A58D9EF4}"/>
+              </a:ext>
+            </a:extLst>
+          </p:cNvPr>
+          <p:cNvPicPr>
+            <a:picLocks noChangeAspect="1"/>
+          </p:cNvPicPr>
+          <p:nvPr/>
+        </p:nvPicPr>
+        <p:blipFill>
+          <a:blip r:embed="rId3"/>
+          <a:stretch>
+            <a:fillRect/>
+          </a:stretch>
+        </p:blipFill>
+        <p:spPr>
+          <a:xfrm>
+            <a:off x="139747" y="1780949"/>
+            <a:ext cx="5894838" cy="3546132"/>
+          </a:xfrm>
+          <a:prstGeom prst="rect">
+            <a:avLst/>
+          </a:prstGeom>
+        </p:spPr>
+      </p:pic>
+    </p:spTree>
+    <p:extLst>
+      <p:ext uri="{BB962C8B-B14F-4D97-AF65-F5344CB8AC3E}">
+        <p14:creationId xmlns:p14="http://schemas.microsoft.com/office/powerpoint/2010/main" val="2733608474"/>
+      </p:ext>
+    </p:extLst>
+  </p:cSld>
+  <p:clrMapOvr>
+    <a:masterClrMapping/>
+  </p:clrMapOvr>
+</p:sld>
+</file>
+
+<file path=ppt/slides/slide13.xml><?xml version="1.0" encoding="utf-8"?>
+<p:sld xmlns:a="http://schemas.openxmlformats.org/drawingml/2006/main" xmlns:r="http://schemas.openxmlformats.org/officeDocument/2006/relationships" xmlns:p="http://schemas.openxmlformats.org/presentationml/2006/main">
+  <p:cSld>
+    <p:spTree>
+      <p:nvGrpSpPr>
+        <p:cNvPr id="1" name=""/>
+        <p:cNvGrpSpPr/>
+        <p:nvPr/>
+      </p:nvGrpSpPr>
+      <p:grpSpPr>
+        <a:xfrm>
+          <a:off x="0" y="0"/>
+          <a:ext cx="0" cy="0"/>
+          <a:chOff x="0" y="0"/>
+          <a:chExt cx="0" cy="0"/>
+        </a:xfrm>
+      </p:grpSpPr>
+      <p:sp>
+        <p:nvSpPr>
+          <p:cNvPr id="2" name="Title 1">
+            <a:extLst>
+              <a:ext uri="{FF2B5EF4-FFF2-40B4-BE49-F238E27FC236}">
+                <a16:creationId xmlns:a16="http://schemas.microsoft.com/office/drawing/2014/main" id="{4B1D8C03-C4EB-8FE9-9F3C-4C5EC3E3404E}"/>
+              </a:ext>
+            </a:extLst>
+          </p:cNvPr>
+          <p:cNvSpPr>
+            <a:spLocks noGrp="1"/>
+          </p:cNvSpPr>
+          <p:nvPr>
+            <p:ph type="title"/>
+          </p:nvPr>
+        </p:nvSpPr>
+        <p:spPr>
+          <a:xfrm>
+            <a:off x="581192" y="702156"/>
+            <a:ext cx="11029616" cy="444256"/>
+          </a:xfrm>
+        </p:spPr>
+        <p:txBody>
+          <a:bodyPr>
+            <a:normAutofit fontScale="90000"/>
+          </a:bodyPr>
+          <a:lstStyle/>
+          <a:p>
+            <a:pPr algn="ctr"/>
+            <a:r>
+              <a:rPr lang="en-IN" dirty="0"/>
+              <a:t>Output of </a:t>
+            </a:r>
+            <a:r>
+              <a:rPr lang="en-IN" dirty="0" err="1"/>
+              <a:t>lfm</a:t>
+            </a:r>
+            <a:r>
+              <a:rPr lang="en-IN" dirty="0"/>
+              <a:t> generated using </a:t>
+            </a:r>
+            <a:r>
+              <a:rPr lang="en-IN" dirty="0" err="1"/>
+              <a:t>gui</a:t>
+            </a:r>
+            <a:endParaRPr lang="en-IN" dirty="0"/>
+          </a:p>
+        </p:txBody>
+      </p:sp>
+      <p:pic>
+        <p:nvPicPr>
+          <p:cNvPr id="5" name="Content Placeholder 4" descr="A graph of a waveform&#10;&#10;AI-generated content may be incorrect.">
+            <a:extLst>
+              <a:ext uri="{FF2B5EF4-FFF2-40B4-BE49-F238E27FC236}">
+                <a16:creationId xmlns:a16="http://schemas.microsoft.com/office/drawing/2014/main" id="{8F8C42A1-C106-C746-70E0-DBD543384034}"/>
+              </a:ext>
+            </a:extLst>
+          </p:cNvPr>
+          <p:cNvPicPr>
+            <a:picLocks noGrp="1" noChangeAspect="1"/>
+          </p:cNvPicPr>
+          <p:nvPr>
+            <p:ph idx="1"/>
+          </p:nvPr>
+        </p:nvPicPr>
+        <p:blipFill>
+          <a:blip r:embed="rId2"/>
+          <a:stretch>
+            <a:fillRect/>
+          </a:stretch>
+        </p:blipFill>
+        <p:spPr>
+          <a:xfrm>
+            <a:off x="791595" y="1612106"/>
+            <a:ext cx="5465904" cy="3633787"/>
+          </a:xfrm>
+        </p:spPr>
+      </p:pic>
+      <p:pic>
+        <p:nvPicPr>
+          <p:cNvPr id="7" name="Picture 6" descr="A blue line graph with white text&#10;&#10;AI-generated content may be incorrect.">
+            <a:extLst>
+              <a:ext uri="{FF2B5EF4-FFF2-40B4-BE49-F238E27FC236}">
+                <a16:creationId xmlns:a16="http://schemas.microsoft.com/office/drawing/2014/main" id="{F9BE61F3-4D0C-30CA-A3D9-4A7C3CA41294}"/>
+              </a:ext>
+            </a:extLst>
+          </p:cNvPr>
+          <p:cNvPicPr>
+            <a:picLocks noChangeAspect="1"/>
+          </p:cNvPicPr>
+          <p:nvPr/>
+        </p:nvPicPr>
+        <p:blipFill>
+          <a:blip r:embed="rId3"/>
+          <a:stretch>
+            <a:fillRect/>
+          </a:stretch>
+        </p:blipFill>
+        <p:spPr>
+          <a:xfrm>
+            <a:off x="6513845" y="1612105"/>
+            <a:ext cx="5465904" cy="3560395"/>
+          </a:xfrm>
+          <a:prstGeom prst="rect">
+            <a:avLst/>
+          </a:prstGeom>
+        </p:spPr>
+      </p:pic>
+    </p:spTree>
+    <p:extLst>
+      <p:ext uri="{BB962C8B-B14F-4D97-AF65-F5344CB8AC3E}">
+        <p14:creationId xmlns:p14="http://schemas.microsoft.com/office/powerpoint/2010/main" val="1047273136"/>
+      </p:ext>
+    </p:extLst>
+  </p:cSld>
+  <p:clrMapOvr>
+    <a:masterClrMapping/>
+  </p:clrMapOvr>
+</p:sld>
+</file>
+
+<file path=ppt/slides/slide14.xml><?xml version="1.0" encoding="utf-8"?>
+<p:sld xmlns:a="http://schemas.openxmlformats.org/drawingml/2006/main" xmlns:r="http://schemas.openxmlformats.org/officeDocument/2006/relationships" xmlns:p="http://schemas.openxmlformats.org/presentationml/2006/main">
+  <p:cSld>
+    <p:spTree>
+      <p:nvGrpSpPr>
+        <p:cNvPr id="1" name=""/>
+        <p:cNvGrpSpPr/>
+        <p:nvPr/>
+      </p:nvGrpSpPr>
+      <p:grpSpPr>
+        <a:xfrm>
+          <a:off x="0" y="0"/>
+          <a:ext cx="0" cy="0"/>
+          <a:chOff x="0" y="0"/>
+          <a:chExt cx="0" cy="0"/>
+        </a:xfrm>
+      </p:grpSpPr>
+      <p:sp>
+        <p:nvSpPr>
+          <p:cNvPr id="2" name="Title 1">
+            <a:extLst>
+              <a:ext uri="{FF2B5EF4-FFF2-40B4-BE49-F238E27FC236}">
+                <a16:creationId xmlns:a16="http://schemas.microsoft.com/office/drawing/2014/main" id="{B360CD81-29E4-82CC-7771-AA5C53457D9D}"/>
+              </a:ext>
+            </a:extLst>
+          </p:cNvPr>
+          <p:cNvSpPr>
+            <a:spLocks noGrp="1"/>
+          </p:cNvSpPr>
+          <p:nvPr>
+            <p:ph type="title"/>
+          </p:nvPr>
+        </p:nvSpPr>
+        <p:spPr>
+          <a:xfrm>
+            <a:off x="581192" y="702156"/>
+            <a:ext cx="11029616" cy="621677"/>
+          </a:xfrm>
+        </p:spPr>
+        <p:txBody>
+          <a:bodyPr/>
+          <a:lstStyle/>
+          <a:p>
+            <a:pPr algn="ctr"/>
+            <a:r>
+              <a:rPr lang="en-IN" dirty="0"/>
+              <a:t>Output from </a:t>
+            </a:r>
+            <a:r>
+              <a:rPr lang="en-IN" dirty="0" err="1"/>
+              <a:t>awg</a:t>
+            </a:r>
+            <a:r>
+              <a:rPr lang="en-IN" dirty="0"/>
+              <a:t> without generating waveform</a:t>
+            </a:r>
+          </a:p>
+        </p:txBody>
+      </p:sp>
+      <p:pic>
+        <p:nvPicPr>
+          <p:cNvPr id="5" name="Content Placeholder 4" descr="A graph with a blue line&#10;&#10;AI-generated content may be incorrect.">
+            <a:extLst>
+              <a:ext uri="{FF2B5EF4-FFF2-40B4-BE49-F238E27FC236}">
+                <a16:creationId xmlns:a16="http://schemas.microsoft.com/office/drawing/2014/main" id="{11775C54-E971-5A7A-C834-2CD9FD6A0982}"/>
+              </a:ext>
+            </a:extLst>
+          </p:cNvPr>
+          <p:cNvPicPr>
+            <a:picLocks noGrp="1" noChangeAspect="1"/>
+          </p:cNvPicPr>
+          <p:nvPr>
+            <p:ph idx="1"/>
+          </p:nvPr>
+        </p:nvPicPr>
+        <p:blipFill>
+          <a:blip r:embed="rId2"/>
+          <a:stretch>
+            <a:fillRect/>
+          </a:stretch>
+        </p:blipFill>
+        <p:spPr>
+          <a:xfrm>
+            <a:off x="1303362" y="2047164"/>
+            <a:ext cx="9387360" cy="4537881"/>
+          </a:xfrm>
+        </p:spPr>
+      </p:pic>
+    </p:spTree>
+    <p:extLst>
+      <p:ext uri="{BB962C8B-B14F-4D97-AF65-F5344CB8AC3E}">
+        <p14:creationId xmlns:p14="http://schemas.microsoft.com/office/powerpoint/2010/main" val="2044026641"/>
+      </p:ext>
+    </p:extLst>
+  </p:cSld>
+  <p:clrMapOvr>
+    <a:masterClrMapping/>
+  </p:clrMapOvr>
+</p:sld>
+</file>
+
 <file path=ppt/slides/slide2.xml><?xml version="1.0" encoding="utf-8"?>
 <p:sld xmlns:a="http://schemas.openxmlformats.org/drawingml/2006/main" xmlns:r="http://schemas.openxmlformats.org/officeDocument/2006/relationships" xmlns:p="http://schemas.openxmlformats.org/presentationml/2006/main">
   <p:cSld>
@@ -5711,6 +6229,15 @@
 </file>
 
 <file path=customXml/item1.xml><?xml version="1.0" encoding="utf-8"?>
+<?mso-contentType ?>
+<FormTemplates xmlns="http://schemas.microsoft.com/sharepoint/v3/contenttype/forms">
+  <Display>DocumentLibraryForm</Display>
+  <Edit>DocumentLibraryForm</Edit>
+  <New>DocumentLibraryForm</New>
+</FormTemplates>
+</file>
+
+<file path=customXml/item2.xml><?xml version="1.0" encoding="utf-8"?>
 <ct:contentTypeSchema xmlns:ct="http://schemas.microsoft.com/office/2006/metadata/contentType" xmlns:ma="http://schemas.microsoft.com/office/2006/metadata/properties/metaAttributes" ct:_="" ma:_="" ma:contentTypeName="Document" ma:contentTypeID="0x01010079F111ED35F8CC479449609E8A0923A6" ma:contentTypeVersion="12" ma:contentTypeDescription="Create a new document." ma:contentTypeScope="" ma:versionID="a410dd7f93c95333ffa1b60ed6adedd1">
   <xsd:schema xmlns:xsd="http://www.w3.org/2001/XMLSchema" xmlns:xs="http://www.w3.org/2001/XMLSchema" xmlns:p="http://schemas.microsoft.com/office/2006/metadata/properties" xmlns:ns2="71af3243-3dd4-4a8d-8c0d-dd76da1f02a5" xmlns:ns3="16c05727-aa75-4e4a-9b5f-8a80a1165891" targetNamespace="http://schemas.microsoft.com/office/2006/metadata/properties" ma:root="true" ma:fieldsID="a936d9baba76aa3866493feff160faab" ns2:_="" ns3:_="">
     <xsd:import namespace="71af3243-3dd4-4a8d-8c0d-dd76da1f02a5"/>
@@ -5931,15 +6458,6 @@
 </ct:contentTypeSchema>
 </file>
 
-<file path=customXml/item2.xml><?xml version="1.0" encoding="utf-8"?>
-<?mso-contentType ?>
-<FormTemplates xmlns="http://schemas.microsoft.com/sharepoint/v3/contenttype/forms">
-  <Display>DocumentLibraryForm</Display>
-  <Edit>DocumentLibraryForm</Edit>
-  <New>DocumentLibraryForm</New>
-</FormTemplates>
-</file>
-
 <file path=customXml/item3.xml><?xml version="1.0" encoding="utf-8"?>
 <p:properties xmlns:p="http://schemas.microsoft.com/office/2006/metadata/properties" xmlns:xsi="http://www.w3.org/2001/XMLSchema-instance" xmlns:pc="http://schemas.microsoft.com/office/infopath/2007/PartnerControls">
   <documentManagement>
@@ -5950,6 +6468,14 @@
 </file>
 
 <file path=customXml/itemProps1.xml><?xml version="1.0" encoding="utf-8"?>
+<ds:datastoreItem xmlns:ds="http://schemas.openxmlformats.org/officeDocument/2006/customXml" ds:itemID="{927BD4C1-B6B1-4715-ABF9-E660A51A4EA0}">
+  <ds:schemaRefs>
+    <ds:schemaRef ds:uri="http://schemas.microsoft.com/sharepoint/v3/contenttype/forms"/>
+  </ds:schemaRefs>
+</ds:datastoreItem>
+</file>
+
+<file path=customXml/itemProps2.xml><?xml version="1.0" encoding="utf-8"?>
 <ds:datastoreItem xmlns:ds="http://schemas.openxmlformats.org/officeDocument/2006/customXml" ds:itemID="{41E7CA09-9778-4414-AE97-8064B12DA30E}">
   <ds:schemaRefs>
     <ds:schemaRef ds:uri="http://schemas.microsoft.com/office/2006/metadata/contentType"/>
@@ -5968,14 +6494,6 @@
 </ds:datastoreItem>
 </file>
 
-<file path=customXml/itemProps2.xml><?xml version="1.0" encoding="utf-8"?>
-<ds:datastoreItem xmlns:ds="http://schemas.openxmlformats.org/officeDocument/2006/customXml" ds:itemID="{927BD4C1-B6B1-4715-ABF9-E660A51A4EA0}">
-  <ds:schemaRefs>
-    <ds:schemaRef ds:uri="http://schemas.microsoft.com/sharepoint/v3/contenttype/forms"/>
-  </ds:schemaRefs>
-</ds:datastoreItem>
-</file>
-
 <file path=customXml/itemProps3.xml><?xml version="1.0" encoding="utf-8"?>
 <ds:datastoreItem xmlns:ds="http://schemas.openxmlformats.org/officeDocument/2006/customXml" ds:itemID="{8D289AE2-D2AE-49D1-AFAC-3A79F6794255}">
   <ds:schemaRefs>

</xml_diff>